<commit_message>
adds end of  chapter 4
</commit_message>
<xml_diff>
--- a/notes_slides/04-flow-of-ctrl.pptx
+++ b/notes_slides/04-flow-of-ctrl.pptx
@@ -21366,6 +21366,15 @@
 </file>
 
 <file path=customXml/item1.xml><?xml version="1.0" encoding="utf-8"?>
+<?mso-contentType ?>
+<FormTemplates xmlns="http://schemas.microsoft.com/sharepoint/v3/contenttype/forms">
+  <Display>DocumentLibraryForm</Display>
+  <Edit>DocumentLibraryForm</Edit>
+  <New>DocumentLibraryForm</New>
+</FormTemplates>
+</file>
+
+<file path=customXml/item2.xml><?xml version="1.0" encoding="utf-8"?>
 <ct:contentTypeSchema xmlns:ct="http://schemas.microsoft.com/office/2006/metadata/contentType" xmlns:ma="http://schemas.microsoft.com/office/2006/metadata/properties/metaAttributes" ct:_="" ma:_="" ma:contentTypeName="Document" ma:contentTypeID="0x01010019AD74F87043FE4BBEC8356891FA714D" ma:contentTypeVersion="18" ma:contentTypeDescription="Create a new document." ma:contentTypeScope="" ma:versionID="0c9bc5073caab55cb2503ba2aa9cde78">
   <xsd:schema xmlns:xsd="http://www.w3.org/2001/XMLSchema" xmlns:xs="http://www.w3.org/2001/XMLSchema" xmlns:p="http://schemas.microsoft.com/office/2006/metadata/properties" xmlns:ns2="9fb8aed9-18ea-4990-b6df-e8f930c0c77e" xmlns:ns3="e3a1f265-f3cd-47b6-9d44-dc00e5335d51" targetNamespace="http://schemas.microsoft.com/office/2006/metadata/properties" ma:root="true" ma:fieldsID="ea388e15b1f598d13bb8617f56dd33c9" ns2:_="" ns3:_="">
     <xsd:import namespace="9fb8aed9-18ea-4990-b6df-e8f930c0c77e"/>
@@ -21620,16 +21629,15 @@
 </ct:contentTypeSchema>
 </file>
 
-<file path=customXml/item2.xml><?xml version="1.0" encoding="utf-8"?>
-<?mso-contentType ?>
-<FormTemplates xmlns="http://schemas.microsoft.com/sharepoint/v3/contenttype/forms">
-  <Display>DocumentLibraryForm</Display>
-  <Edit>DocumentLibraryForm</Edit>
-  <New>DocumentLibraryForm</New>
-</FormTemplates>
+<file path=customXml/itemProps1.xml><?xml version="1.0" encoding="utf-8"?>
+<ds:datastoreItem xmlns:ds="http://schemas.openxmlformats.org/officeDocument/2006/customXml" ds:itemID="{0935929B-F44C-4971-BE86-A4F3BF0A8BFC}">
+  <ds:schemaRefs>
+    <ds:schemaRef ds:uri="http://schemas.microsoft.com/sharepoint/v3/contenttype/forms"/>
+  </ds:schemaRefs>
+</ds:datastoreItem>
 </file>
 
-<file path=customXml/itemProps1.xml><?xml version="1.0" encoding="utf-8"?>
+<file path=customXml/itemProps2.xml><?xml version="1.0" encoding="utf-8"?>
 <ds:datastoreItem xmlns:ds="http://schemas.openxmlformats.org/officeDocument/2006/customXml" ds:itemID="{8D3CAD65-D05D-4EC6-BDDD-B6E3EDDBC1D6}">
   <ds:schemaRefs>
     <ds:schemaRef ds:uri="http://schemas.microsoft.com/office/2006/metadata/contentType"/>
@@ -21646,12 +21654,4 @@
     <ds:schemaRef ds:uri="http://schemas.microsoft.com/internal/obd"/>
   </ds:schemaRefs>
 </ds:datastoreItem>
-</file>
-
-<file path=customXml/itemProps2.xml><?xml version="1.0" encoding="utf-8"?>
-<ds:datastoreItem xmlns:ds="http://schemas.openxmlformats.org/officeDocument/2006/customXml" ds:itemID="{0935929B-F44C-4971-BE86-A4F3BF0A8BFC}">
-  <ds:schemaRefs>
-    <ds:schemaRef ds:uri="http://schemas.microsoft.com/sharepoint/v3/contenttype/forms"/>
-  </ds:schemaRefs>
-</ds:datastoreItem>
 </file>
</xml_diff>